<commit_message>
acces: changement de mot de passe (écran /compte), admin IT, diagnostic + guide Vercel · présentation à jour
</commit_message>
<xml_diff>
--- a/AGL-JuriCompliance-Presentation.pptx
+++ b/AGL-JuriCompliance-Presentation.pptx
@@ -188,7 +188,13 @@
           <a:p>
             <a:r>
               <a:rPr lang="fr-FR" dirty="0"/>
-              <a:t>Les conséquences concrètes : des textes qui nous échappent, des assignations approximatives, des preuves introuvables et des retards que personne ne voit.</a:t>
+              <a:t>Les conséquences concrètes : des textes qui nous échappent, des assignations approximatives, des preuves introuvables, des retards que personne ne voit.</a:t>
+            </a:r>
+          </a:p>
+          <a:p>
+            <a:r>
+              <a:rPr lang="fr-FR" dirty="0"/>
+              <a:t>S'y ajoute un point de sécurité que nous avons mesuré : la BU était choisie dans le navigateur, l'API croyait l'en-tête envoyé par le client : n'importe qui pouvait se déclarer Direction Juridique. C'est corrigé, j'y viens.</a:t>
             </a:r>
           </a:p>
           <a:p>
@@ -200,7 +206,7 @@
           <a:p>
             <a:r>
               <a:rPr lang="fr-FR" dirty="0"/>
-              <a:t>Ne pas entrer dans le détail technique ici : c'est l'objet de la slide suivante.</a:t>
+              <a:t>Ne pas entrer dans le détail technique ici : c'est l'objet des slides suivantes.</a:t>
             </a:r>
           </a:p>
         </p:txBody>
@@ -253,7 +259,13 @@
           <a:p>
             <a:r>
               <a:rPr lang="fr-FR" dirty="0"/>
-              <a:t>En haut la source : un PDF ou une image, rien de plus. Au centre l'extraction par IA, qui transforme un document en actes distincts — un Journal Officiel contient des dizaines d'actes, on ne les fusionne jamais.</a:t>
+              <a:t>En haut la source : on peut déposer plusieurs PDF d'un coup. Ils sont analysés l'un après l'autre — c'est plus lent, mais chaque résultat est conservé dès qu'il arrive et un échec n'annule pas les autres.</a:t>
+            </a:r>
+          </a:p>
+          <a:p>
+            <a:r>
+              <a:rPr lang="fr-FR" dirty="0"/>
+              <a:t>L'extraction transforme un document en actes distincts : un Journal Officiel contient des dizaines d'actes, on ne les fusionne jamais.</a:t>
             </a:r>
           </a:p>
           <a:p>
@@ -265,13 +277,13 @@
           <a:p>
             <a:r>
               <a:rPr lang="fr-FR" dirty="0"/>
-              <a:t>La persistance porte déjà le versioning et le journal : la traçabilité n'est pas une option ajoutée après coup.</a:t>
+              <a:t>Quatrième couche, la persistance et l'accès : les 7 tables portent la traçabilité, et les accès sont gérés côté serveur — mot de passe haché, session signée.</a:t>
             </a:r>
           </a:p>
           <a:p>
             <a:r>
               <a:rPr lang="fr-FR" dirty="0"/>
-              <a:t>Et enfin six écrans, une API qui applique exactement les mêmes règles que l'interface.</a:t>
+              <a:t>Enfin les écrans : six, et la même règle des deux côtés de l'API.</a:t>
             </a:r>
           </a:p>
         </p:txBody>
@@ -389,25 +401,25 @@
           <a:p>
             <a:r>
               <a:rPr lang="fr-FR" dirty="0"/>
-              <a:t>Premièrement l'historique : on ne remplace pas une donnée, on la fige. Une fiche modifiée trois fois reste consultable dans ses trois états, avec l'auteur, la date et le détail des champs modifiés.</a:t>
+              <a:t>D'abord, un scan ne se perd jamais. L'IA coûte des tokens : tant qu'un document n'est pas enregistré, il reste dans la liste des documents scannés. Changer d'onglet, quitter la page, revenir le lendemain, déposer un autre JO : rien ne s'efface. Nous avons d'ailleurs trouvé la cause d'une perte de scans : l'enregistrement dans le navigateur échouait en silence quand le document dépassait la capacité du stockage.</a:t>
             </a:r>
           </a:p>
           <a:p>
             <a:r>
               <a:rPr lang="fr-FR" dirty="0"/>
-              <a:t>Deuxièmement le cloisonnement : contrôle réel, dans l'interface comme dans l'API.</a:t>
+              <a:t>Ensuite les accès : un mot de passe par direction, haché, et une session signée par le serveur. Concrètement, un appel HTTP qui prétend être la Direction Juridique sans session est rejeté — c'est vérifié.</a:t>
             </a:r>
           </a:p>
           <a:p>
             <a:r>
               <a:rPr lang="fr-FR" dirty="0"/>
-              <a:t>Troisièmement la fidélité : l'IA recopie les articles mot à mot et ne construit jamais une référence. Si l'information n'est pas dans le document, la fiche affiche « N/A » et le juridique corrige.</a:t>
+              <a:t>Puis la fidélité : l'IA recopie les articles mot à mot et ne construit jamais une référence. Si l'information n'est pas dans le document, la fiche affiche N/A et le juridique corrige.</a:t>
             </a:r>
           </a:p>
           <a:p>
             <a:r>
               <a:rPr lang="fr-FR" dirty="0"/>
-              <a:t>Quatrièmement la fraîcheur : on sait toujours de quand datent les données et de quand date la version de l'outil affichée.</a:t>
+              <a:t>Enfin l'historique : on ne remplace pas une donnée, on la fige. Une fiche modifiée trois fois reste consultable dans ses trois états, avec l'auteur, la date et le détail des champs modifiés.</a:t>
             </a:r>
           </a:p>
         </p:txBody>
@@ -460,25 +472,31 @@
           <a:p>
             <a:r>
               <a:rPr lang="fr-FR" dirty="0"/>
-              <a:t>Le schéma Dataverse est déjà écrit dans le code, avec les listes de choix, les relations et les rôles de sécurité. Le seul point à basculer est l'identité : le sélecteur de direction sera remplacé par Entra ID et les Web Roles.</a:t>
+              <a:t>Le schéma Dataverse est déjà écrit dans le code, avec les listes de choix, les relations et les rôles de sécurité.</a:t>
             </a:r>
           </a:p>
           <a:p>
             <a:r>
               <a:rPr lang="fr-FR" dirty="0"/>
-              <a:t>Concrètement, la suite est cadrée : recréer le schéma, brancher l'API, activer l'auditing natif, puis piloter la recette avec les directions.</a:t>
+              <a:t>Pour l'identité, la bascule est courte et bien délimitée : deux points seulement dans le code, lireSession côté serveur et la pastille d'identité côté interface. Tout le reste — les droits, les filtres par direction, les refus 403 — est déjà dans la forme attendue par Power Pages.</a:t>
             </a:r>
           </a:p>
           <a:p>
             <a:r>
               <a:rPr lang="fr-FR" dirty="0"/>
-              <a:t>Je propose de terminer par la démo : le même parcours que la présentation, sur des données réelles.</a:t>
+              <a:t>Concrètement, la suite est cadrée : recréer le schéma, brancher l'API, activer l'auditing natif, puis basculer l'authentification sur Entra ID avec les directions.</a:t>
             </a:r>
           </a:p>
           <a:p>
             <a:r>
               <a:rPr lang="fr-FR" dirty="0"/>
-              <a:t>Le code et la documentation sont sur le dépôt indiqué en bas de slide — je vous invite à les parcourir.</a:t>
+              <a:t>Je propose de terminer par la démo : connexion, assignation d'un document, approbation, puis la vue immersive du texte.</a:t>
+            </a:r>
+          </a:p>
+          <a:p>
+            <a:r>
+              <a:rPr lang="fr-FR" dirty="0"/>
+              <a:t>Le code et la documentation sont sur le dépôt indiqué en bas de slide.</a:t>
             </a:r>
           </a:p>
         </p:txBody>
@@ -935,7 +953,7 @@
                 <a:latin typeface="Segoe UI"/>
                 <a:cs typeface="Segoe UI"/>
               </a:rPr>
-              <a:t>Du Journal Officiel à la conformité terrain : capter, extraire, assigner, piloter.</a:t>
+              <a:t>Du Journal Officiel à la conformité terrain : capter, extraire, assigner, piloter, prouver.</a:t>
             </a:r>
             <a:endParaRPr lang="fr-FR" sz="100"/>
           </a:p>
@@ -950,7 +968,7 @@
         <p:spPr>
           <a:xfrm>
             <a:off x="711200" y="4724400"/>
-            <a:ext cx="1749044" cy="381000"/>
+            <a:ext cx="1613916" cy="381000"/>
           </a:xfrm>
           <a:prstGeom prst="roundRect">
             <a:avLst>
@@ -990,7 +1008,7 @@
         <p:spPr>
           <a:xfrm>
             <a:off x="711200" y="4724400"/>
-            <a:ext cx="1749044" cy="381000"/>
+            <a:ext cx="1613916" cy="381000"/>
           </a:xfrm>
           <a:prstGeom prst="rect">
             <a:avLst/>
@@ -1018,7 +1036,7 @@
                 <a:latin typeface="Segoe UI"/>
                 <a:cs typeface="Segoe UI"/>
               </a:rPr>
-              <a:t>Prototype fonctionnel</a:t>
+              <a:t>Accès par direction</a:t>
             </a:r>
             <a:endParaRPr lang="fr-FR" sz="100"/>
           </a:p>
@@ -1032,8 +1050,8 @@
         </p:nvSpPr>
         <p:spPr>
           <a:xfrm>
-            <a:off x="2612644" y="4724400"/>
-            <a:ext cx="1140968" cy="381000"/>
+            <a:off x="2477516" y="4724400"/>
+            <a:ext cx="1478788" cy="381000"/>
           </a:xfrm>
           <a:prstGeom prst="roundRect">
             <a:avLst>
@@ -1072,8 +1090,8 @@
         </p:nvSpPr>
         <p:spPr>
           <a:xfrm>
-            <a:off x="2612644" y="4724400"/>
-            <a:ext cx="1140968" cy="381000"/>
+            <a:off x="2477516" y="4724400"/>
+            <a:ext cx="1478788" cy="381000"/>
           </a:xfrm>
           <a:prstGeom prst="rect">
             <a:avLst/>
@@ -1101,7 +1119,7 @@
                 <a:latin typeface="Segoe UI"/>
                 <a:cs typeface="Segoe UI"/>
               </a:rPr>
-              <a:t>8 directions</a:t>
+              <a:t>Scan jamais perdu</a:t>
             </a:r>
             <a:endParaRPr lang="fr-FR" sz="100"/>
           </a:p>
@@ -1115,8 +1133,8 @@
         </p:nvSpPr>
         <p:spPr>
           <a:xfrm>
-            <a:off x="3906012" y="4724400"/>
-            <a:ext cx="1749044" cy="381000"/>
+            <a:off x="4108704" y="4724400"/>
+            <a:ext cx="1411224" cy="381000"/>
           </a:xfrm>
           <a:prstGeom prst="roundRect">
             <a:avLst>
@@ -1155,8 +1173,8 @@
         </p:nvSpPr>
         <p:spPr>
           <a:xfrm>
-            <a:off x="3906012" y="4724400"/>
-            <a:ext cx="1749044" cy="381000"/>
+            <a:off x="4108704" y="4724400"/>
+            <a:ext cx="1411224" cy="381000"/>
           </a:xfrm>
           <a:prstGeom prst="rect">
             <a:avLst/>
@@ -1184,7 +1202,7 @@
                 <a:latin typeface="Segoe UI"/>
                 <a:cs typeface="Segoe UI"/>
               </a:rPr>
-              <a:t>Traçabilité intégrale</a:t>
+              <a:t>Traçabilité SCD2</a:t>
             </a:r>
             <a:endParaRPr lang="fr-FR" sz="100"/>
           </a:p>
@@ -1198,7 +1216,7 @@
         </p:nvSpPr>
         <p:spPr>
           <a:xfrm>
-            <a:off x="5807456" y="4724400"/>
+            <a:off x="5672328" y="4724400"/>
             <a:ext cx="2289556" cy="381000"/>
           </a:xfrm>
           <a:prstGeom prst="roundRect">
@@ -1238,7 +1256,7 @@
         </p:nvSpPr>
         <p:spPr>
           <a:xfrm>
-            <a:off x="5807456" y="4724400"/>
+            <a:off x="5672328" y="4724400"/>
             <a:ext cx="2289556" cy="381000"/>
           </a:xfrm>
           <a:prstGeom prst="rect">
@@ -3139,7 +3157,7 @@
                 <a:latin typeface="Segoe UI"/>
                 <a:cs typeface="Segoe UI"/>
               </a:rPr>
-              <a:t>Texte manqué, assignation floue, preuves éparpillées, actions en retard invisibles, aucune piste d'audit.</a:t>
+              <a:t>Texte manqué, assignation floue, preuves éparpillées, actions en retard invisibles — et aucun vrai cloisonnement des accès.</a:t>
             </a:r>
             <a:endParaRPr lang="fr-FR" sz="100"/>
           </a:p>
@@ -3992,7 +4010,7 @@
                 <a:latin typeface="Segoe UI"/>
                 <a:cs typeface="Segoe UI"/>
               </a:rPr>
-              <a:t>PDF ou image du Journal Officiel. Des fichiers de test sont fournis dans l'application pour la démonstration.</a:t>
+              <a:t>Un ou plusieurs PDF / images déposés d'un coup ; analysés l'un après l'autre, chaque résultat conservé.</a:t>
             </a:r>
             <a:endParaRPr lang="fr-FR" sz="100"/>
           </a:p>
@@ -4067,7 +4085,7 @@
                 <a:latin typeface="Segoe UI"/>
                 <a:cs typeface="Segoe UI"/>
               </a:rPr>
-              <a:t>PDF · image</a:t>
+              <a:t>N fichiers</a:t>
             </a:r>
             <a:endParaRPr lang="fr-FR" sz="100"/>
           </a:p>
@@ -4906,7 +4924,7 @@
                 <a:latin typeface="Segoe UI"/>
                 <a:cs typeface="Segoe UI"/>
               </a:rPr>
-              <a:t>Persistance</a:t>
+              <a:t>Persistance &amp; accès</a:t>
             </a:r>
             <a:endParaRPr lang="fr-FR" sz="100"/>
           </a:p>
@@ -4952,7 +4970,7 @@
                 <a:latin typeface="Segoe UI"/>
                 <a:cs typeface="Segoe UI"/>
               </a:rPr>
-              <a:t>Prisma 6 / PostgreSQL : 7 tables, versions figées et journal — la traçabilité est dans le modèle, pas dans un rapport.</a:t>
+              <a:t>Prisma 6 / PostgreSQL : 7 tables, versions figées, journal — et les accès : scrypt + session signée par le serveur.</a:t>
             </a:r>
             <a:endParaRPr lang="fr-FR" sz="100"/>
           </a:p>
@@ -5272,7 +5290,7 @@
                 <a:latin typeface="Segoe UI"/>
                 <a:cs typeface="Segoe UI"/>
               </a:rPr>
-              <a:t>Écrans &amp; API</a:t>
+              <a:t>Écrans &amp; accès par BU</a:t>
             </a:r>
             <a:endParaRPr lang="fr-FR" sz="100"/>
           </a:p>
@@ -5318,7 +5336,7 @@
                 <a:latin typeface="Segoe UI"/>
                 <a:cs typeface="Segoe UI"/>
               </a:rPr>
-              <a:t>6 écrans (pilotage, nouvelle alerte, approbations, rejets, historique, mémo) et 6 routes API, les mêmes règles des deux côtés.</a:t>
+              <a:t>6 écrans + 6 routes API, session obligatoire : chaque direction ne voit que ses fiches, avec son propre mot de passe.</a:t>
             </a:r>
             <a:endParaRPr lang="fr-FR" sz="100"/>
           </a:p>
@@ -5853,7 +5871,7 @@
                 <a:latin typeface="Segoe UI"/>
                 <a:cs typeface="Segoe UI"/>
               </a:rPr>
-              <a:t>ESLint</a:t>
+              <a:t>scrypt</a:t>
             </a:r>
             <a:endParaRPr lang="fr-FR" sz="100"/>
           </a:p>
@@ -5868,7 +5886,7 @@
         <p:spPr>
           <a:xfrm>
             <a:off x="6935216" y="5791200"/>
-            <a:ext cx="395224" cy="279400"/>
+            <a:ext cx="971296" cy="279400"/>
           </a:xfrm>
           <a:prstGeom prst="roundRect">
             <a:avLst>
@@ -5902,7 +5920,7 @@
         <p:spPr>
           <a:xfrm>
             <a:off x="6935216" y="5791200"/>
-            <a:ext cx="395224" cy="279400"/>
+            <a:ext cx="971296" cy="279400"/>
           </a:xfrm>
           <a:prstGeom prst="rect">
             <a:avLst/>
@@ -5930,7 +5948,7 @@
                 <a:latin typeface="Segoe UI"/>
                 <a:cs typeface="Segoe UI"/>
               </a:rPr>
-              <a:t>zod</a:t>
+              <a:t>session HMAC</a:t>
             </a:r>
             <a:endParaRPr lang="fr-FR" sz="100"/>
           </a:p>
@@ -5944,8 +5962,8 @@
         </p:nvSpPr>
         <p:spPr>
           <a:xfrm>
-            <a:off x="7432040" y="5791200"/>
-            <a:ext cx="651256" cy="279400"/>
+            <a:off x="8008112" y="5791200"/>
+            <a:ext cx="779272" cy="279400"/>
           </a:xfrm>
           <a:prstGeom prst="roundRect">
             <a:avLst>
@@ -5978,8 +5996,8 @@
         </p:nvSpPr>
         <p:spPr>
           <a:xfrm>
-            <a:off x="7432040" y="5791200"/>
-            <a:ext cx="651256" cy="279400"/>
+            <a:off x="8008112" y="5791200"/>
+            <a:ext cx="779272" cy="279400"/>
           </a:xfrm>
           <a:prstGeom prst="rect">
             <a:avLst/>
@@ -6007,7 +6025,7 @@
                 <a:latin typeface="Segoe UI"/>
                 <a:cs typeface="Segoe UI"/>
               </a:rPr>
-              <a:t>pdf-lib</a:t>
+              <a:t>IndexedDB</a:t>
             </a:r>
             <a:endParaRPr lang="fr-FR" sz="100"/>
           </a:p>
@@ -7809,7 +7827,7 @@
                 <a:latin typeface="Segoe UI"/>
                 <a:cs typeface="Segoe UI"/>
               </a:rPr>
-              <a:t>Crée les alertes, assigne les directions, corrige le texte source, fait avancer le flux et retraite les rejets. Elle ne touche jamais à la conformité d'une direction.</a:t>
+              <a:t>Crée les alertes, assigne les directions, corrige le texte source, fait avancer le flux et retraite les rejets. Vue générale : elle ne touche jamais à la conformité d'une direction.</a:t>
             </a:r>
             <a:endParaRPr lang="fr-FR" sz="100"/>
           </a:p>
@@ -8098,7 +8116,7 @@
                 <a:latin typeface="Segoe UI"/>
                 <a:cs typeface="Segoe UI"/>
               </a:rPr>
-              <a:t>Elle ne voit et ne modifie que ses propres fiches — Direction Juridique comprise, sans exception. Contrôle appliqué dans l'interface comme dans l'API (401 / 403).</a:t>
+              <a:t>Connexion obligatoire, mot de passe propre à la direction : elle ne voit et ne modifie que ses fiches — Direction Juridique comprise. Écrans Assignation et Rejet absents, API en 403.</a:t>
             </a:r>
             <a:endParaRPr lang="fr-FR" sz="100"/>
           </a:p>
@@ -8637,7 +8655,7 @@
             <a:off x="1091062" y="2157862"/>
             <a:ext cx="230876" cy="230876"/>
           </a:xfrm>
-          <a:prstGeom prst="ellipse">
+          <a:prstGeom prst="circularArrow">
             <a:avLst/>
           </a:prstGeom>
           <a:solidFill>
@@ -8664,8 +8682,142 @@
         </p:nvSpPr>
         <p:spPr>
           <a:xfrm>
-            <a:off x="1198971" y="2213072"/>
-            <a:ext cx="15057" cy="70267"/>
+            <a:off x="965200" y="2641600"/>
+            <a:ext cx="1993900" cy="431800"/>
+          </a:xfrm>
+          <a:prstGeom prst="rect">
+            <a:avLst/>
+          </a:prstGeom>
+          <a:noFill/>
+          <a:ln>
+            <a:noFill/>
+          </a:ln>
+          <a:effectLst/>
+        </p:spPr>
+        <p:txBody>
+          <a:bodyPr wrap="square" lIns="0" tIns="0" rIns="0" bIns="0" anchor="t">
+            <a:noAutofit/>
+          </a:bodyPr>
+          <a:lstStyle/>
+          <a:p>
+            <a:pPr>
+              <a:lnSpc>
+                <a:spcPct val="106000"/>
+              </a:lnSpc>
+              <a:buNone/>
+            </a:pPr>
+            <a:r>
+              <a:rPr lang="fr-FR" sz="1250" b="1" dirty="0">
+                <a:solidFill>
+                  <a:srgbClr val="1C3359"/>
+                </a:solidFill>
+                <a:latin typeface="Segoe UI"/>
+                <a:cs typeface="Segoe UI"/>
+              </a:rPr>
+              <a:t>Un scan ne se perd jamais</a:t>
+            </a:r>
+            <a:endParaRPr lang="fr-FR" sz="100"/>
+          </a:p>
+        </p:txBody>
+      </p:sp>
+      <p:sp>
+        <p:nvSpPr>
+          <p:cNvPr id="14" name="forme"/>
+          <p:cNvSpPr/>
+          <p:nvPr/>
+        </p:nvSpPr>
+        <p:spPr>
+          <a:xfrm>
+            <a:off x="965200" y="3098800"/>
+            <a:ext cx="1993900" cy="990600"/>
+          </a:xfrm>
+          <a:prstGeom prst="rect">
+            <a:avLst/>
+          </a:prstGeom>
+          <a:noFill/>
+          <a:ln>
+            <a:noFill/>
+          </a:ln>
+          <a:effectLst/>
+        </p:spPr>
+        <p:txBody>
+          <a:bodyPr wrap="square" lIns="0" tIns="0" rIns="0" bIns="0" anchor="t">
+            <a:noAutofit/>
+          </a:bodyPr>
+          <a:lstStyle/>
+          <a:p>
+            <a:pPr>
+              <a:lnSpc>
+                <a:spcPct val="125000"/>
+              </a:lnSpc>
+              <a:buNone/>
+            </a:pPr>
+            <a:r>
+              <a:rPr lang="fr-FR" sz="950" b="0" dirty="0">
+                <a:solidFill>
+                  <a:srgbClr val="4C5C72"/>
+                </a:solidFill>
+                <a:latin typeface="Segoe UI"/>
+                <a:cs typeface="Segoe UI"/>
+              </a:rPr>
+              <a:t>Un document scanné reste enregistré tant qu'il n'est pas assigné : changer d'onglet, quitter la page, revenir le lendemain — rien ne disparaît.</a:t>
+            </a:r>
+            <a:endParaRPr lang="fr-FR" sz="100"/>
+          </a:p>
+        </p:txBody>
+      </p:sp>
+      <p:sp>
+        <p:nvSpPr>
+          <p:cNvPr id="15" name="forme"/>
+          <p:cNvSpPr/>
+          <p:nvPr/>
+        </p:nvSpPr>
+        <p:spPr>
+          <a:xfrm>
+            <a:off x="3467100" y="1778000"/>
+            <a:ext cx="2501900" cy="2489200"/>
+          </a:xfrm>
+          <a:prstGeom prst="roundRect">
+            <a:avLst>
+              <a:gd name="adj" fmla="val 12245"/>
+            </a:avLst>
+          </a:prstGeom>
+          <a:solidFill>
+            <a:srgbClr val="FFFFFF"/>
+          </a:solidFill>
+          <a:ln w="9525" cap="flat">
+            <a:solidFill>
+              <a:srgbClr val="DCE3EE"/>
+            </a:solidFill>
+            <a:prstDash val="solid"/>
+            <a:flat/>
+          </a:ln>
+          <a:effectLst>
+            <a:outerShdw blurRad="127000" dist="31750" dir="5400000" rotWithShape="0">
+              <a:srgbClr val="0B1A30">
+                <a:alpha val="8000"/>
+              </a:srgbClr>
+            </a:outerShdw>
+          </a:effectLst>
+        </p:spPr>
+        <p:txBody>
+          <a:bodyPr/>
+          <a:lstStyle/>
+          <a:p>
+            <a:endParaRPr lang="fr-FR"/>
+          </a:p>
+        </p:txBody>
+      </p:sp>
+      <p:sp>
+        <p:nvSpPr>
+          <p:cNvPr id="16" name="forme"/>
+          <p:cNvSpPr/>
+          <p:nvPr/>
+        </p:nvSpPr>
+        <p:spPr>
+          <a:xfrm>
+            <a:off x="3467100" y="1778000"/>
+            <a:ext cx="50800" cy="2489200"/>
           </a:xfrm>
           <a:prstGeom prst="roundRect">
             <a:avLst>
@@ -8673,31 +8825,31 @@
             </a:avLst>
           </a:prstGeom>
           <a:solidFill>
-            <a:srgbClr val="1C3359"/>
-          </a:solidFill>
-          <a:ln>
-            <a:noFill/>
-          </a:ln>
-          <a:effectLst/>
-        </p:spPr>
-        <p:txBody>
-          <a:bodyPr/>
-          <a:lstStyle/>
-          <a:p>
-            <a:endParaRPr lang="fr-FR"/>
-          </a:p>
-        </p:txBody>
-      </p:sp>
-      <p:sp>
-        <p:nvSpPr>
-          <p:cNvPr id="14" name="forme"/>
-          <p:cNvSpPr/>
-          <p:nvPr/>
-        </p:nvSpPr>
-        <p:spPr>
-          <a:xfrm>
-            <a:off x="1203990" y="2265771"/>
-            <a:ext cx="65248" cy="15057"/>
+            <a:srgbClr val="B6AD6E"/>
+          </a:solidFill>
+          <a:ln>
+            <a:noFill/>
+          </a:ln>
+          <a:effectLst/>
+        </p:spPr>
+        <p:txBody>
+          <a:bodyPr/>
+          <a:lstStyle/>
+          <a:p>
+            <a:endParaRPr lang="fr-FR"/>
+          </a:p>
+        </p:txBody>
+      </p:sp>
+      <p:sp>
+        <p:nvSpPr>
+          <p:cNvPr id="17" name="forme"/>
+          <p:cNvSpPr/>
+          <p:nvPr/>
+        </p:nvSpPr>
+        <p:spPr>
+          <a:xfrm>
+            <a:off x="3721100" y="2032000"/>
+            <a:ext cx="482600" cy="482600"/>
           </a:xfrm>
           <a:prstGeom prst="roundRect">
             <a:avLst>
@@ -8722,13 +8874,693 @@
       </p:sp>
       <p:sp>
         <p:nvSpPr>
-          <p:cNvPr id="15" name="forme"/>
-          <p:cNvSpPr/>
-          <p:nvPr/>
-        </p:nvSpPr>
-        <p:spPr>
-          <a:xfrm>
-            <a:off x="965200" y="2641600"/>
+          <p:cNvPr id="18" name="forme"/>
+          <p:cNvSpPr/>
+          <p:nvPr/>
+        </p:nvSpPr>
+        <p:spPr>
+          <a:xfrm>
+            <a:off x="3887114" y="2162881"/>
+            <a:ext cx="150571" cy="155590"/>
+          </a:xfrm>
+          <a:prstGeom prst="blockArc">
+            <a:avLst>
+              <a:gd name="adj1" fmla="val 10800000"/>
+              <a:gd name="adj2" fmla="val 0"/>
+              <a:gd name="adj3" fmla="val 17000"/>
+            </a:avLst>
+          </a:prstGeom>
+          <a:solidFill>
+            <a:srgbClr val="FFFFFF"/>
+          </a:solidFill>
+          <a:ln>
+            <a:noFill/>
+          </a:ln>
+          <a:effectLst/>
+        </p:spPr>
+        <p:txBody>
+          <a:bodyPr/>
+          <a:lstStyle/>
+          <a:p>
+            <a:endParaRPr lang="fr-FR"/>
+          </a:p>
+        </p:txBody>
+      </p:sp>
+      <p:sp>
+        <p:nvSpPr>
+          <p:cNvPr id="19" name="forme"/>
+          <p:cNvSpPr/>
+          <p:nvPr/>
+        </p:nvSpPr>
+        <p:spPr>
+          <a:xfrm>
+            <a:off x="3857000" y="2253224"/>
+            <a:ext cx="210800" cy="125476"/>
+          </a:xfrm>
+          <a:prstGeom prst="roundRect">
+            <a:avLst>
+              <a:gd name="adj" fmla="val 50000"/>
+            </a:avLst>
+          </a:prstGeom>
+          <a:solidFill>
+            <a:srgbClr val="FFFFFF"/>
+          </a:solidFill>
+          <a:ln>
+            <a:noFill/>
+          </a:ln>
+          <a:effectLst/>
+        </p:spPr>
+        <p:txBody>
+          <a:bodyPr/>
+          <a:lstStyle/>
+          <a:p>
+            <a:endParaRPr lang="fr-FR"/>
+          </a:p>
+        </p:txBody>
+      </p:sp>
+      <p:sp>
+        <p:nvSpPr>
+          <p:cNvPr id="20" name="forme"/>
+          <p:cNvSpPr/>
+          <p:nvPr/>
+        </p:nvSpPr>
+        <p:spPr>
+          <a:xfrm>
+            <a:off x="3942324" y="2290867"/>
+            <a:ext cx="40152" cy="40152"/>
+          </a:xfrm>
+          <a:prstGeom prst="ellipse">
+            <a:avLst/>
+          </a:prstGeom>
+          <a:solidFill>
+            <a:srgbClr val="1C3359"/>
+          </a:solidFill>
+          <a:ln>
+            <a:noFill/>
+          </a:ln>
+          <a:effectLst/>
+        </p:spPr>
+        <p:txBody>
+          <a:bodyPr/>
+          <a:lstStyle/>
+          <a:p>
+            <a:endParaRPr lang="fr-FR"/>
+          </a:p>
+        </p:txBody>
+      </p:sp>
+      <p:sp>
+        <p:nvSpPr>
+          <p:cNvPr id="21" name="forme"/>
+          <p:cNvSpPr/>
+          <p:nvPr/>
+        </p:nvSpPr>
+        <p:spPr>
+          <a:xfrm>
+            <a:off x="3954871" y="2313452"/>
+            <a:ext cx="15057" cy="35133"/>
+          </a:xfrm>
+          <a:prstGeom prst="rect">
+            <a:avLst/>
+          </a:prstGeom>
+          <a:solidFill>
+            <a:srgbClr val="1C3359"/>
+          </a:solidFill>
+          <a:ln>
+            <a:noFill/>
+          </a:ln>
+          <a:effectLst/>
+        </p:spPr>
+        <p:txBody>
+          <a:bodyPr/>
+          <a:lstStyle/>
+          <a:p>
+            <a:endParaRPr lang="fr-FR"/>
+          </a:p>
+        </p:txBody>
+      </p:sp>
+      <p:sp>
+        <p:nvSpPr>
+          <p:cNvPr id="22" name="forme"/>
+          <p:cNvSpPr/>
+          <p:nvPr/>
+        </p:nvSpPr>
+        <p:spPr>
+          <a:xfrm>
+            <a:off x="3721100" y="2641600"/>
+            <a:ext cx="1993900" cy="431800"/>
+          </a:xfrm>
+          <a:prstGeom prst="rect">
+            <a:avLst/>
+          </a:prstGeom>
+          <a:noFill/>
+          <a:ln>
+            <a:noFill/>
+          </a:ln>
+          <a:effectLst/>
+        </p:spPr>
+        <p:txBody>
+          <a:bodyPr wrap="square" lIns="0" tIns="0" rIns="0" bIns="0" anchor="t">
+            <a:noAutofit/>
+          </a:bodyPr>
+          <a:lstStyle/>
+          <a:p>
+            <a:pPr>
+              <a:lnSpc>
+                <a:spcPct val="106000"/>
+              </a:lnSpc>
+              <a:buNone/>
+            </a:pPr>
+            <a:r>
+              <a:rPr lang="fr-FR" sz="1250" b="1" dirty="0">
+                <a:solidFill>
+                  <a:srgbClr val="1C3359"/>
+                </a:solidFill>
+                <a:latin typeface="Segoe UI"/>
+                <a:cs typeface="Segoe UI"/>
+              </a:rPr>
+              <a:t>Accès réels, par direction</a:t>
+            </a:r>
+            <a:endParaRPr lang="fr-FR" sz="100"/>
+          </a:p>
+        </p:txBody>
+      </p:sp>
+      <p:sp>
+        <p:nvSpPr>
+          <p:cNvPr id="23" name="forme"/>
+          <p:cNvSpPr/>
+          <p:nvPr/>
+        </p:nvSpPr>
+        <p:spPr>
+          <a:xfrm>
+            <a:off x="3721100" y="3098800"/>
+            <a:ext cx="1993900" cy="990600"/>
+          </a:xfrm>
+          <a:prstGeom prst="rect">
+            <a:avLst/>
+          </a:prstGeom>
+          <a:noFill/>
+          <a:ln>
+            <a:noFill/>
+          </a:ln>
+          <a:effectLst/>
+        </p:spPr>
+        <p:txBody>
+          <a:bodyPr wrap="square" lIns="0" tIns="0" rIns="0" bIns="0" anchor="t">
+            <a:noAutofit/>
+          </a:bodyPr>
+          <a:lstStyle/>
+          <a:p>
+            <a:pPr>
+              <a:lnSpc>
+                <a:spcPct val="125000"/>
+              </a:lnSpc>
+              <a:buNone/>
+            </a:pPr>
+            <a:r>
+              <a:rPr lang="fr-FR" sz="950" b="0" dirty="0">
+                <a:solidFill>
+                  <a:srgbClr val="4C5C72"/>
+                </a:solidFill>
+                <a:latin typeface="Segoe UI"/>
+                <a:cs typeface="Segoe UI"/>
+              </a:rPr>
+              <a:t>Un mot de passe par direction, mots de passe scrypt, session signée par le serveur : impossible de se faire passer pour une autre BU.</a:t>
+            </a:r>
+            <a:endParaRPr lang="fr-FR" sz="100"/>
+          </a:p>
+        </p:txBody>
+      </p:sp>
+      <p:sp>
+        <p:nvSpPr>
+          <p:cNvPr id="24" name="forme"/>
+          <p:cNvSpPr/>
+          <p:nvPr/>
+        </p:nvSpPr>
+        <p:spPr>
+          <a:xfrm>
+            <a:off x="6223000" y="1778000"/>
+            <a:ext cx="2501900" cy="2489200"/>
+          </a:xfrm>
+          <a:prstGeom prst="roundRect">
+            <a:avLst>
+              <a:gd name="adj" fmla="val 12245"/>
+            </a:avLst>
+          </a:prstGeom>
+          <a:solidFill>
+            <a:srgbClr val="FFFFFF"/>
+          </a:solidFill>
+          <a:ln w="9525" cap="flat">
+            <a:solidFill>
+              <a:srgbClr val="DCE3EE"/>
+            </a:solidFill>
+            <a:prstDash val="solid"/>
+            <a:flat/>
+          </a:ln>
+          <a:effectLst>
+            <a:outerShdw blurRad="127000" dist="31750" dir="5400000" rotWithShape="0">
+              <a:srgbClr val="0B1A30">
+                <a:alpha val="8000"/>
+              </a:srgbClr>
+            </a:outerShdw>
+          </a:effectLst>
+        </p:spPr>
+        <p:txBody>
+          <a:bodyPr/>
+          <a:lstStyle/>
+          <a:p>
+            <a:endParaRPr lang="fr-FR"/>
+          </a:p>
+        </p:txBody>
+      </p:sp>
+      <p:sp>
+        <p:nvSpPr>
+          <p:cNvPr id="25" name="forme"/>
+          <p:cNvSpPr/>
+          <p:nvPr/>
+        </p:nvSpPr>
+        <p:spPr>
+          <a:xfrm>
+            <a:off x="6223000" y="1778000"/>
+            <a:ext cx="50800" cy="2489200"/>
+          </a:xfrm>
+          <a:prstGeom prst="roundRect">
+            <a:avLst>
+              <a:gd name="adj" fmla="val 50000"/>
+            </a:avLst>
+          </a:prstGeom>
+          <a:solidFill>
+            <a:srgbClr val="B6AD6E"/>
+          </a:solidFill>
+          <a:ln>
+            <a:noFill/>
+          </a:ln>
+          <a:effectLst/>
+        </p:spPr>
+        <p:txBody>
+          <a:bodyPr/>
+          <a:lstStyle/>
+          <a:p>
+            <a:endParaRPr lang="fr-FR"/>
+          </a:p>
+        </p:txBody>
+      </p:sp>
+      <p:sp>
+        <p:nvSpPr>
+          <p:cNvPr id="26" name="forme"/>
+          <p:cNvSpPr/>
+          <p:nvPr/>
+        </p:nvSpPr>
+        <p:spPr>
+          <a:xfrm>
+            <a:off x="6477000" y="2032000"/>
+            <a:ext cx="482600" cy="482600"/>
+          </a:xfrm>
+          <a:prstGeom prst="roundRect">
+            <a:avLst>
+              <a:gd name="adj" fmla="val 50000"/>
+            </a:avLst>
+          </a:prstGeom>
+          <a:solidFill>
+            <a:srgbClr val="1C3359"/>
+          </a:solidFill>
+          <a:ln>
+            <a:noFill/>
+          </a:ln>
+          <a:effectLst/>
+        </p:spPr>
+        <p:txBody>
+          <a:bodyPr/>
+          <a:lstStyle/>
+          <a:p>
+            <a:endParaRPr lang="fr-FR"/>
+          </a:p>
+        </p:txBody>
+      </p:sp>
+      <p:sp>
+        <p:nvSpPr>
+          <p:cNvPr id="27" name="forme"/>
+          <p:cNvSpPr/>
+          <p:nvPr/>
+        </p:nvSpPr>
+        <p:spPr>
+          <a:xfrm rot="2700000">
+            <a:off x="6620429" y="2305924"/>
+            <a:ext cx="77795" cy="30114"/>
+          </a:xfrm>
+          <a:prstGeom prst="roundRect">
+            <a:avLst>
+              <a:gd name="adj" fmla="val 50000"/>
+            </a:avLst>
+          </a:prstGeom>
+          <a:solidFill>
+            <a:srgbClr val="FFFFFF"/>
+          </a:solidFill>
+          <a:ln>
+            <a:noFill/>
+          </a:ln>
+          <a:effectLst/>
+        </p:spPr>
+        <p:txBody>
+          <a:bodyPr/>
+          <a:lstStyle/>
+          <a:p>
+            <a:endParaRPr lang="fr-FR"/>
+          </a:p>
+        </p:txBody>
+      </p:sp>
+      <p:sp>
+        <p:nvSpPr>
+          <p:cNvPr id="28" name="forme"/>
+          <p:cNvSpPr/>
+          <p:nvPr/>
+        </p:nvSpPr>
+        <p:spPr>
+          <a:xfrm rot="-2700000">
+            <a:off x="6663091" y="2275810"/>
+            <a:ext cx="163119" cy="30114"/>
+          </a:xfrm>
+          <a:prstGeom prst="roundRect">
+            <a:avLst>
+              <a:gd name="adj" fmla="val 50000"/>
+            </a:avLst>
+          </a:prstGeom>
+          <a:solidFill>
+            <a:srgbClr val="FFFFFF"/>
+          </a:solidFill>
+          <a:ln>
+            <a:noFill/>
+          </a:ln>
+          <a:effectLst/>
+        </p:spPr>
+        <p:txBody>
+          <a:bodyPr/>
+          <a:lstStyle/>
+          <a:p>
+            <a:endParaRPr lang="fr-FR"/>
+          </a:p>
+        </p:txBody>
+      </p:sp>
+      <p:sp>
+        <p:nvSpPr>
+          <p:cNvPr id="29" name="forme"/>
+          <p:cNvSpPr/>
+          <p:nvPr/>
+        </p:nvSpPr>
+        <p:spPr>
+          <a:xfrm>
+            <a:off x="6477000" y="2641600"/>
+            <a:ext cx="1993900" cy="431800"/>
+          </a:xfrm>
+          <a:prstGeom prst="rect">
+            <a:avLst/>
+          </a:prstGeom>
+          <a:noFill/>
+          <a:ln>
+            <a:noFill/>
+          </a:ln>
+          <a:effectLst/>
+        </p:spPr>
+        <p:txBody>
+          <a:bodyPr wrap="square" lIns="0" tIns="0" rIns="0" bIns="0" anchor="t">
+            <a:noAutofit/>
+          </a:bodyPr>
+          <a:lstStyle/>
+          <a:p>
+            <a:pPr>
+              <a:lnSpc>
+                <a:spcPct val="106000"/>
+              </a:lnSpc>
+              <a:buNone/>
+            </a:pPr>
+            <a:r>
+              <a:rPr lang="fr-FR" sz="1250" b="1" dirty="0">
+                <a:solidFill>
+                  <a:srgbClr val="1C3359"/>
+                </a:solidFill>
+                <a:latin typeface="Segoe UI"/>
+                <a:cs typeface="Segoe UI"/>
+              </a:rPr>
+              <a:t>Fidélité de l'extraction</a:t>
+            </a:r>
+            <a:endParaRPr lang="fr-FR" sz="100"/>
+          </a:p>
+        </p:txBody>
+      </p:sp>
+      <p:sp>
+        <p:nvSpPr>
+          <p:cNvPr id="30" name="forme"/>
+          <p:cNvSpPr/>
+          <p:nvPr/>
+        </p:nvSpPr>
+        <p:spPr>
+          <a:xfrm>
+            <a:off x="6477000" y="3098800"/>
+            <a:ext cx="1993900" cy="990600"/>
+          </a:xfrm>
+          <a:prstGeom prst="rect">
+            <a:avLst/>
+          </a:prstGeom>
+          <a:noFill/>
+          <a:ln>
+            <a:noFill/>
+          </a:ln>
+          <a:effectLst/>
+        </p:spPr>
+        <p:txBody>
+          <a:bodyPr wrap="square" lIns="0" tIns="0" rIns="0" bIns="0" anchor="t">
+            <a:noAutofit/>
+          </a:bodyPr>
+          <a:lstStyle/>
+          <a:p>
+            <a:pPr>
+              <a:lnSpc>
+                <a:spcPct val="125000"/>
+              </a:lnSpc>
+              <a:buNone/>
+            </a:pPr>
+            <a:r>
+              <a:rPr lang="fr-FR" sz="950" b="0" dirty="0">
+                <a:solidFill>
+                  <a:srgbClr val="4C5C72"/>
+                </a:solidFill>
+                <a:latin typeface="Segoe UI"/>
+                <a:cs typeface="Segoe UI"/>
+              </a:rPr>
+              <a:t>Articles copiés mot à mot, références complètes, URL jamais inventée : « N/A » si l'information manque.</a:t>
+            </a:r>
+            <a:endParaRPr lang="fr-FR" sz="100"/>
+          </a:p>
+        </p:txBody>
+      </p:sp>
+      <p:sp>
+        <p:nvSpPr>
+          <p:cNvPr id="31" name="forme"/>
+          <p:cNvSpPr/>
+          <p:nvPr/>
+        </p:nvSpPr>
+        <p:spPr>
+          <a:xfrm>
+            <a:off x="8978900" y="1778000"/>
+            <a:ext cx="2501900" cy="2489200"/>
+          </a:xfrm>
+          <a:prstGeom prst="roundRect">
+            <a:avLst>
+              <a:gd name="adj" fmla="val 12245"/>
+            </a:avLst>
+          </a:prstGeom>
+          <a:solidFill>
+            <a:srgbClr val="FFFFFF"/>
+          </a:solidFill>
+          <a:ln w="9525" cap="flat">
+            <a:solidFill>
+              <a:srgbClr val="DCE3EE"/>
+            </a:solidFill>
+            <a:prstDash val="solid"/>
+            <a:flat/>
+          </a:ln>
+          <a:effectLst>
+            <a:outerShdw blurRad="127000" dist="31750" dir="5400000" rotWithShape="0">
+              <a:srgbClr val="0B1A30">
+                <a:alpha val="8000"/>
+              </a:srgbClr>
+            </a:outerShdw>
+          </a:effectLst>
+        </p:spPr>
+        <p:txBody>
+          <a:bodyPr/>
+          <a:lstStyle/>
+          <a:p>
+            <a:endParaRPr lang="fr-FR"/>
+          </a:p>
+        </p:txBody>
+      </p:sp>
+      <p:sp>
+        <p:nvSpPr>
+          <p:cNvPr id="32" name="forme"/>
+          <p:cNvSpPr/>
+          <p:nvPr/>
+        </p:nvSpPr>
+        <p:spPr>
+          <a:xfrm>
+            <a:off x="8978900" y="1778000"/>
+            <a:ext cx="50800" cy="2489200"/>
+          </a:xfrm>
+          <a:prstGeom prst="roundRect">
+            <a:avLst>
+              <a:gd name="adj" fmla="val 50000"/>
+            </a:avLst>
+          </a:prstGeom>
+          <a:solidFill>
+            <a:srgbClr val="B6AD6E"/>
+          </a:solidFill>
+          <a:ln>
+            <a:noFill/>
+          </a:ln>
+          <a:effectLst/>
+        </p:spPr>
+        <p:txBody>
+          <a:bodyPr/>
+          <a:lstStyle/>
+          <a:p>
+            <a:endParaRPr lang="fr-FR"/>
+          </a:p>
+        </p:txBody>
+      </p:sp>
+      <p:sp>
+        <p:nvSpPr>
+          <p:cNvPr id="33" name="forme"/>
+          <p:cNvSpPr/>
+          <p:nvPr/>
+        </p:nvSpPr>
+        <p:spPr>
+          <a:xfrm>
+            <a:off x="9232900" y="2032000"/>
+            <a:ext cx="482600" cy="482600"/>
+          </a:xfrm>
+          <a:prstGeom prst="roundRect">
+            <a:avLst>
+              <a:gd name="adj" fmla="val 50000"/>
+            </a:avLst>
+          </a:prstGeom>
+          <a:solidFill>
+            <a:srgbClr val="1C3359"/>
+          </a:solidFill>
+          <a:ln>
+            <a:noFill/>
+          </a:ln>
+          <a:effectLst/>
+        </p:spPr>
+        <p:txBody>
+          <a:bodyPr/>
+          <a:lstStyle/>
+          <a:p>
+            <a:endParaRPr lang="fr-FR"/>
+          </a:p>
+        </p:txBody>
+      </p:sp>
+      <p:sp>
+        <p:nvSpPr>
+          <p:cNvPr id="34" name="forme"/>
+          <p:cNvSpPr/>
+          <p:nvPr/>
+        </p:nvSpPr>
+        <p:spPr>
+          <a:xfrm>
+            <a:off x="9358762" y="2157862"/>
+            <a:ext cx="230876" cy="230876"/>
+          </a:xfrm>
+          <a:prstGeom prst="ellipse">
+            <a:avLst/>
+          </a:prstGeom>
+          <a:solidFill>
+            <a:srgbClr val="FFFFFF"/>
+          </a:solidFill>
+          <a:ln>
+            <a:noFill/>
+          </a:ln>
+          <a:effectLst/>
+        </p:spPr>
+        <p:txBody>
+          <a:bodyPr/>
+          <a:lstStyle/>
+          <a:p>
+            <a:endParaRPr lang="fr-FR"/>
+          </a:p>
+        </p:txBody>
+      </p:sp>
+      <p:sp>
+        <p:nvSpPr>
+          <p:cNvPr id="35" name="forme"/>
+          <p:cNvSpPr/>
+          <p:nvPr/>
+        </p:nvSpPr>
+        <p:spPr>
+          <a:xfrm>
+            <a:off x="9466671" y="2213072"/>
+            <a:ext cx="15057" cy="70267"/>
+          </a:xfrm>
+          <a:prstGeom prst="roundRect">
+            <a:avLst>
+              <a:gd name="adj" fmla="val 50000"/>
+            </a:avLst>
+          </a:prstGeom>
+          <a:solidFill>
+            <a:srgbClr val="1C3359"/>
+          </a:solidFill>
+          <a:ln>
+            <a:noFill/>
+          </a:ln>
+          <a:effectLst/>
+        </p:spPr>
+        <p:txBody>
+          <a:bodyPr/>
+          <a:lstStyle/>
+          <a:p>
+            <a:endParaRPr lang="fr-FR"/>
+          </a:p>
+        </p:txBody>
+      </p:sp>
+      <p:sp>
+        <p:nvSpPr>
+          <p:cNvPr id="36" name="forme"/>
+          <p:cNvSpPr/>
+          <p:nvPr/>
+        </p:nvSpPr>
+        <p:spPr>
+          <a:xfrm>
+            <a:off x="9471690" y="2265771"/>
+            <a:ext cx="65248" cy="15057"/>
+          </a:xfrm>
+          <a:prstGeom prst="roundRect">
+            <a:avLst>
+              <a:gd name="adj" fmla="val 50000"/>
+            </a:avLst>
+          </a:prstGeom>
+          <a:solidFill>
+            <a:srgbClr val="1C3359"/>
+          </a:solidFill>
+          <a:ln>
+            <a:noFill/>
+          </a:ln>
+          <a:effectLst/>
+        </p:spPr>
+        <p:txBody>
+          <a:bodyPr/>
+          <a:lstStyle/>
+          <a:p>
+            <a:endParaRPr lang="fr-FR"/>
+          </a:p>
+        </p:txBody>
+      </p:sp>
+      <p:sp>
+        <p:nvSpPr>
+          <p:cNvPr id="37" name="forme"/>
+          <p:cNvSpPr/>
+          <p:nvPr/>
+        </p:nvSpPr>
+        <p:spPr>
+          <a:xfrm>
+            <a:off x="9232900" y="2641600"/>
             <a:ext cx="1993900" cy="431800"/>
           </a:xfrm>
           <a:prstGeom prst="rect">
@@ -8768,13 +9600,13 @@
       </p:sp>
       <p:sp>
         <p:nvSpPr>
-          <p:cNvPr id="16" name="forme"/>
-          <p:cNvSpPr/>
-          <p:nvPr/>
-        </p:nvSpPr>
-        <p:spPr>
-          <a:xfrm>
-            <a:off x="965200" y="3098800"/>
+          <p:cNvPr id="38" name="forme"/>
+          <p:cNvSpPr/>
+          <p:nvPr/>
+        </p:nvSpPr>
+        <p:spPr>
+          <a:xfrm>
+            <a:off x="9232900" y="3098800"/>
             <a:ext cx="1993900" cy="990600"/>
           </a:xfrm>
           <a:prstGeom prst="rect">
@@ -8806,7 +9638,7 @@
                 <a:latin typeface="Segoe UI"/>
                 <a:cs typeface="Segoe UI"/>
               </a:rPr>
-              <a:t>Chaque enregistrement fige la version précédente (validFrom, validTo, isCurrent) et écrit dans un journal lisible.</a:t>
+              <a:t>Chaque enregistrement fige la version précédente et alimente un journal lisible : qui, quoi, quand, champs modifiés.</a:t>
             </a:r>
             <a:endParaRPr lang="fr-FR" sz="100"/>
           </a:p>
@@ -8814,56 +9646,46 @@
       </p:sp>
       <p:sp>
         <p:nvSpPr>
-          <p:cNvPr id="17" name="forme"/>
-          <p:cNvSpPr/>
-          <p:nvPr/>
-        </p:nvSpPr>
-        <p:spPr>
-          <a:xfrm>
-            <a:off x="3467100" y="1778000"/>
-            <a:ext cx="2501900" cy="2489200"/>
+          <p:cNvPr id="39" name="forme"/>
+          <p:cNvSpPr/>
+          <p:nvPr/>
+        </p:nvSpPr>
+        <p:spPr>
+          <a:xfrm>
+            <a:off x="711200" y="4597400"/>
+            <a:ext cx="10769600" cy="1422400"/>
           </a:xfrm>
           <a:prstGeom prst="roundRect">
             <a:avLst>
-              <a:gd name="adj" fmla="val 12245"/>
+              <a:gd name="adj" fmla="val 21429"/>
             </a:avLst>
           </a:prstGeom>
           <a:solidFill>
-            <a:srgbClr val="FFFFFF"/>
-          </a:solidFill>
-          <a:ln w="9525" cap="flat">
-            <a:solidFill>
-              <a:srgbClr val="DCE3EE"/>
-            </a:solidFill>
-            <a:prstDash val="solid"/>
-            <a:flat/>
-          </a:ln>
-          <a:effectLst>
-            <a:outerShdw blurRad="127000" dist="31750" dir="5400000" rotWithShape="0">
-              <a:srgbClr val="0B1A30">
-                <a:alpha val="8000"/>
-              </a:srgbClr>
-            </a:outerShdw>
-          </a:effectLst>
-        </p:spPr>
-        <p:txBody>
-          <a:bodyPr/>
-          <a:lstStyle/>
-          <a:p>
-            <a:endParaRPr lang="fr-FR"/>
-          </a:p>
-        </p:txBody>
-      </p:sp>
-      <p:sp>
-        <p:nvSpPr>
-          <p:cNvPr id="18" name="forme"/>
-          <p:cNvSpPr/>
-          <p:nvPr/>
-        </p:nvSpPr>
-        <p:spPr>
-          <a:xfrm>
-            <a:off x="3467100" y="1778000"/>
-            <a:ext cx="50800" cy="2489200"/>
+            <a:srgbClr val="1C3359"/>
+          </a:solidFill>
+          <a:ln>
+            <a:noFill/>
+          </a:ln>
+          <a:effectLst/>
+        </p:spPr>
+        <p:txBody>
+          <a:bodyPr/>
+          <a:lstStyle/>
+          <a:p>
+            <a:endParaRPr lang="fr-FR"/>
+          </a:p>
+        </p:txBody>
+      </p:sp>
+      <p:sp>
+        <p:nvSpPr>
+          <p:cNvPr id="40" name="forme"/>
+          <p:cNvSpPr/>
+          <p:nvPr/>
+        </p:nvSpPr>
+        <p:spPr>
+          <a:xfrm>
+            <a:off x="990600" y="5054600"/>
+            <a:ext cx="508000" cy="508000"/>
           </a:xfrm>
           <a:prstGeom prst="roundRect">
             <a:avLst>
@@ -8871,779 +9693,7 @@
             </a:avLst>
           </a:prstGeom>
           <a:solidFill>
-            <a:srgbClr val="B6AD6E"/>
-          </a:solidFill>
-          <a:ln>
-            <a:noFill/>
-          </a:ln>
-          <a:effectLst/>
-        </p:spPr>
-        <p:txBody>
-          <a:bodyPr/>
-          <a:lstStyle/>
-          <a:p>
-            <a:endParaRPr lang="fr-FR"/>
-          </a:p>
-        </p:txBody>
-      </p:sp>
-      <p:sp>
-        <p:nvSpPr>
-          <p:cNvPr id="19" name="forme"/>
-          <p:cNvSpPr/>
-          <p:nvPr/>
-        </p:nvSpPr>
-        <p:spPr>
-          <a:xfrm>
-            <a:off x="3721100" y="2032000"/>
-            <a:ext cx="482600" cy="482600"/>
-          </a:xfrm>
-          <a:prstGeom prst="roundRect">
-            <a:avLst>
-              <a:gd name="adj" fmla="val 50000"/>
-            </a:avLst>
-          </a:prstGeom>
-          <a:solidFill>
-            <a:srgbClr val="1C3359"/>
-          </a:solidFill>
-          <a:ln>
-            <a:noFill/>
-          </a:ln>
-          <a:effectLst/>
-        </p:spPr>
-        <p:txBody>
-          <a:bodyPr/>
-          <a:lstStyle/>
-          <a:p>
-            <a:endParaRPr lang="fr-FR"/>
-          </a:p>
-        </p:txBody>
-      </p:sp>
-      <p:sp>
-        <p:nvSpPr>
-          <p:cNvPr id="20" name="forme"/>
-          <p:cNvSpPr/>
-          <p:nvPr/>
-        </p:nvSpPr>
-        <p:spPr>
-          <a:xfrm>
-            <a:off x="3887114" y="2162881"/>
-            <a:ext cx="150571" cy="155590"/>
-          </a:xfrm>
-          <a:prstGeom prst="blockArc">
-            <a:avLst>
-              <a:gd name="adj1" fmla="val 10800000"/>
-              <a:gd name="adj2" fmla="val 0"/>
-              <a:gd name="adj3" fmla="val 17000"/>
-            </a:avLst>
-          </a:prstGeom>
-          <a:solidFill>
-            <a:srgbClr val="FFFFFF"/>
-          </a:solidFill>
-          <a:ln>
-            <a:noFill/>
-          </a:ln>
-          <a:effectLst/>
-        </p:spPr>
-        <p:txBody>
-          <a:bodyPr/>
-          <a:lstStyle/>
-          <a:p>
-            <a:endParaRPr lang="fr-FR"/>
-          </a:p>
-        </p:txBody>
-      </p:sp>
-      <p:sp>
-        <p:nvSpPr>
-          <p:cNvPr id="21" name="forme"/>
-          <p:cNvSpPr/>
-          <p:nvPr/>
-        </p:nvSpPr>
-        <p:spPr>
-          <a:xfrm>
-            <a:off x="3857000" y="2253224"/>
-            <a:ext cx="210800" cy="125476"/>
-          </a:xfrm>
-          <a:prstGeom prst="roundRect">
-            <a:avLst>
-              <a:gd name="adj" fmla="val 50000"/>
-            </a:avLst>
-          </a:prstGeom>
-          <a:solidFill>
-            <a:srgbClr val="FFFFFF"/>
-          </a:solidFill>
-          <a:ln>
-            <a:noFill/>
-          </a:ln>
-          <a:effectLst/>
-        </p:spPr>
-        <p:txBody>
-          <a:bodyPr/>
-          <a:lstStyle/>
-          <a:p>
-            <a:endParaRPr lang="fr-FR"/>
-          </a:p>
-        </p:txBody>
-      </p:sp>
-      <p:sp>
-        <p:nvSpPr>
-          <p:cNvPr id="22" name="forme"/>
-          <p:cNvSpPr/>
-          <p:nvPr/>
-        </p:nvSpPr>
-        <p:spPr>
-          <a:xfrm>
-            <a:off x="3942324" y="2290867"/>
-            <a:ext cx="40152" cy="40152"/>
-          </a:xfrm>
-          <a:prstGeom prst="ellipse">
-            <a:avLst/>
-          </a:prstGeom>
-          <a:solidFill>
-            <a:srgbClr val="1C3359"/>
-          </a:solidFill>
-          <a:ln>
-            <a:noFill/>
-          </a:ln>
-          <a:effectLst/>
-        </p:spPr>
-        <p:txBody>
-          <a:bodyPr/>
-          <a:lstStyle/>
-          <a:p>
-            <a:endParaRPr lang="fr-FR"/>
-          </a:p>
-        </p:txBody>
-      </p:sp>
-      <p:sp>
-        <p:nvSpPr>
-          <p:cNvPr id="23" name="forme"/>
-          <p:cNvSpPr/>
-          <p:nvPr/>
-        </p:nvSpPr>
-        <p:spPr>
-          <a:xfrm>
-            <a:off x="3954871" y="2313452"/>
-            <a:ext cx="15057" cy="35133"/>
-          </a:xfrm>
-          <a:prstGeom prst="rect">
-            <a:avLst/>
-          </a:prstGeom>
-          <a:solidFill>
-            <a:srgbClr val="1C3359"/>
-          </a:solidFill>
-          <a:ln>
-            <a:noFill/>
-          </a:ln>
-          <a:effectLst/>
-        </p:spPr>
-        <p:txBody>
-          <a:bodyPr/>
-          <a:lstStyle/>
-          <a:p>
-            <a:endParaRPr lang="fr-FR"/>
-          </a:p>
-        </p:txBody>
-      </p:sp>
-      <p:sp>
-        <p:nvSpPr>
-          <p:cNvPr id="24" name="forme"/>
-          <p:cNvSpPr/>
-          <p:nvPr/>
-        </p:nvSpPr>
-        <p:spPr>
-          <a:xfrm>
-            <a:off x="3721100" y="2641600"/>
-            <a:ext cx="1993900" cy="431800"/>
-          </a:xfrm>
-          <a:prstGeom prst="rect">
-            <a:avLst/>
-          </a:prstGeom>
-          <a:noFill/>
-          <a:ln>
-            <a:noFill/>
-          </a:ln>
-          <a:effectLst/>
-        </p:spPr>
-        <p:txBody>
-          <a:bodyPr wrap="square" lIns="0" tIns="0" rIns="0" bIns="0" anchor="t">
-            <a:noAutofit/>
-          </a:bodyPr>
-          <a:lstStyle/>
-          <a:p>
-            <a:pPr>
-              <a:lnSpc>
-                <a:spcPct val="106000"/>
-              </a:lnSpc>
-              <a:buNone/>
-            </a:pPr>
-            <a:r>
-              <a:rPr lang="fr-FR" sz="1250" b="1" dirty="0">
-                <a:solidFill>
-                  <a:srgbClr val="1C3359"/>
-                </a:solidFill>
-                <a:latin typeface="Segoe UI"/>
-                <a:cs typeface="Segoe UI"/>
-              </a:rPr>
-              <a:t>Cloisonnement strict</a:t>
-            </a:r>
-            <a:endParaRPr lang="fr-FR" sz="100"/>
-          </a:p>
-        </p:txBody>
-      </p:sp>
-      <p:sp>
-        <p:nvSpPr>
-          <p:cNvPr id="25" name="forme"/>
-          <p:cNvSpPr/>
-          <p:nvPr/>
-        </p:nvSpPr>
-        <p:spPr>
-          <a:xfrm>
-            <a:off x="3721100" y="3098800"/>
-            <a:ext cx="1993900" cy="990600"/>
-          </a:xfrm>
-          <a:prstGeom prst="rect">
-            <a:avLst/>
-          </a:prstGeom>
-          <a:noFill/>
-          <a:ln>
-            <a:noFill/>
-          </a:ln>
-          <a:effectLst/>
-        </p:spPr>
-        <p:txBody>
-          <a:bodyPr wrap="square" lIns="0" tIns="0" rIns="0" bIns="0" anchor="t">
-            <a:noAutofit/>
-          </a:bodyPr>
-          <a:lstStyle/>
-          <a:p>
-            <a:pPr>
-              <a:lnSpc>
-                <a:spcPct val="125000"/>
-              </a:lnSpc>
-              <a:buNone/>
-            </a:pPr>
-            <a:r>
-              <a:rPr lang="fr-FR" sz="950" b="0" dirty="0">
-                <a:solidFill>
-                  <a:srgbClr val="4C5C72"/>
-                </a:solidFill>
-                <a:latin typeface="Segoe UI"/>
-                <a:cs typeface="Segoe UI"/>
-              </a:rPr>
-              <a:t>Une direction ne modifie que ses propres fichiers. La matrice d'accès est appliquée côté interface et côté API, pas seulement affichée.</a:t>
-            </a:r>
-            <a:endParaRPr lang="fr-FR" sz="100"/>
-          </a:p>
-        </p:txBody>
-      </p:sp>
-      <p:sp>
-        <p:nvSpPr>
-          <p:cNvPr id="26" name="forme"/>
-          <p:cNvSpPr/>
-          <p:nvPr/>
-        </p:nvSpPr>
-        <p:spPr>
-          <a:xfrm>
-            <a:off x="6223000" y="1778000"/>
-            <a:ext cx="2501900" cy="2489200"/>
-          </a:xfrm>
-          <a:prstGeom prst="roundRect">
-            <a:avLst>
-              <a:gd name="adj" fmla="val 12245"/>
-            </a:avLst>
-          </a:prstGeom>
-          <a:solidFill>
-            <a:srgbClr val="FFFFFF"/>
-          </a:solidFill>
-          <a:ln w="9525" cap="flat">
-            <a:solidFill>
-              <a:srgbClr val="DCE3EE"/>
-            </a:solidFill>
-            <a:prstDash val="solid"/>
-            <a:flat/>
-          </a:ln>
-          <a:effectLst>
-            <a:outerShdw blurRad="127000" dist="31750" dir="5400000" rotWithShape="0">
-              <a:srgbClr val="0B1A30">
-                <a:alpha val="8000"/>
-              </a:srgbClr>
-            </a:outerShdw>
-          </a:effectLst>
-        </p:spPr>
-        <p:txBody>
-          <a:bodyPr/>
-          <a:lstStyle/>
-          <a:p>
-            <a:endParaRPr lang="fr-FR"/>
-          </a:p>
-        </p:txBody>
-      </p:sp>
-      <p:sp>
-        <p:nvSpPr>
-          <p:cNvPr id="27" name="forme"/>
-          <p:cNvSpPr/>
-          <p:nvPr/>
-        </p:nvSpPr>
-        <p:spPr>
-          <a:xfrm>
-            <a:off x="6223000" y="1778000"/>
-            <a:ext cx="50800" cy="2489200"/>
-          </a:xfrm>
-          <a:prstGeom prst="roundRect">
-            <a:avLst>
-              <a:gd name="adj" fmla="val 50000"/>
-            </a:avLst>
-          </a:prstGeom>
-          <a:solidFill>
-            <a:srgbClr val="B6AD6E"/>
-          </a:solidFill>
-          <a:ln>
-            <a:noFill/>
-          </a:ln>
-          <a:effectLst/>
-        </p:spPr>
-        <p:txBody>
-          <a:bodyPr/>
-          <a:lstStyle/>
-          <a:p>
-            <a:endParaRPr lang="fr-FR"/>
-          </a:p>
-        </p:txBody>
-      </p:sp>
-      <p:sp>
-        <p:nvSpPr>
-          <p:cNvPr id="28" name="forme"/>
-          <p:cNvSpPr/>
-          <p:nvPr/>
-        </p:nvSpPr>
-        <p:spPr>
-          <a:xfrm>
-            <a:off x="6477000" y="2032000"/>
-            <a:ext cx="482600" cy="482600"/>
-          </a:xfrm>
-          <a:prstGeom prst="roundRect">
-            <a:avLst>
-              <a:gd name="adj" fmla="val 50000"/>
-            </a:avLst>
-          </a:prstGeom>
-          <a:solidFill>
-            <a:srgbClr val="1C3359"/>
-          </a:solidFill>
-          <a:ln>
-            <a:noFill/>
-          </a:ln>
-          <a:effectLst/>
-        </p:spPr>
-        <p:txBody>
-          <a:bodyPr/>
-          <a:lstStyle/>
-          <a:p>
-            <a:endParaRPr lang="fr-FR"/>
-          </a:p>
-        </p:txBody>
-      </p:sp>
-      <p:sp>
-        <p:nvSpPr>
-          <p:cNvPr id="29" name="forme"/>
-          <p:cNvSpPr/>
-          <p:nvPr/>
-        </p:nvSpPr>
-        <p:spPr>
-          <a:xfrm rot="2700000">
-            <a:off x="6620429" y="2305924"/>
-            <a:ext cx="77795" cy="30114"/>
-          </a:xfrm>
-          <a:prstGeom prst="roundRect">
-            <a:avLst>
-              <a:gd name="adj" fmla="val 50000"/>
-            </a:avLst>
-          </a:prstGeom>
-          <a:solidFill>
-            <a:srgbClr val="FFFFFF"/>
-          </a:solidFill>
-          <a:ln>
-            <a:noFill/>
-          </a:ln>
-          <a:effectLst/>
-        </p:spPr>
-        <p:txBody>
-          <a:bodyPr/>
-          <a:lstStyle/>
-          <a:p>
-            <a:endParaRPr lang="fr-FR"/>
-          </a:p>
-        </p:txBody>
-      </p:sp>
-      <p:sp>
-        <p:nvSpPr>
-          <p:cNvPr id="30" name="forme"/>
-          <p:cNvSpPr/>
-          <p:nvPr/>
-        </p:nvSpPr>
-        <p:spPr>
-          <a:xfrm rot="-2700000">
-            <a:off x="6663091" y="2275810"/>
-            <a:ext cx="163119" cy="30114"/>
-          </a:xfrm>
-          <a:prstGeom prst="roundRect">
-            <a:avLst>
-              <a:gd name="adj" fmla="val 50000"/>
-            </a:avLst>
-          </a:prstGeom>
-          <a:solidFill>
-            <a:srgbClr val="FFFFFF"/>
-          </a:solidFill>
-          <a:ln>
-            <a:noFill/>
-          </a:ln>
-          <a:effectLst/>
-        </p:spPr>
-        <p:txBody>
-          <a:bodyPr/>
-          <a:lstStyle/>
-          <a:p>
-            <a:endParaRPr lang="fr-FR"/>
-          </a:p>
-        </p:txBody>
-      </p:sp>
-      <p:sp>
-        <p:nvSpPr>
-          <p:cNvPr id="31" name="forme"/>
-          <p:cNvSpPr/>
-          <p:nvPr/>
-        </p:nvSpPr>
-        <p:spPr>
-          <a:xfrm>
-            <a:off x="6477000" y="2641600"/>
-            <a:ext cx="1993900" cy="431800"/>
-          </a:xfrm>
-          <a:prstGeom prst="rect">
-            <a:avLst/>
-          </a:prstGeom>
-          <a:noFill/>
-          <a:ln>
-            <a:noFill/>
-          </a:ln>
-          <a:effectLst/>
-        </p:spPr>
-        <p:txBody>
-          <a:bodyPr wrap="square" lIns="0" tIns="0" rIns="0" bIns="0" anchor="t">
-            <a:noAutofit/>
-          </a:bodyPr>
-          <a:lstStyle/>
-          <a:p>
-            <a:pPr>
-              <a:lnSpc>
-                <a:spcPct val="106000"/>
-              </a:lnSpc>
-              <a:buNone/>
-            </a:pPr>
-            <a:r>
-              <a:rPr lang="fr-FR" sz="1250" b="1" dirty="0">
-                <a:solidFill>
-                  <a:srgbClr val="1C3359"/>
-                </a:solidFill>
-                <a:latin typeface="Segoe UI"/>
-                <a:cs typeface="Segoe UI"/>
-              </a:rPr>
-              <a:t>Fidélité de l'extraction</a:t>
-            </a:r>
-            <a:endParaRPr lang="fr-FR" sz="100"/>
-          </a:p>
-        </p:txBody>
-      </p:sp>
-      <p:sp>
-        <p:nvSpPr>
-          <p:cNvPr id="32" name="forme"/>
-          <p:cNvSpPr/>
-          <p:nvPr/>
-        </p:nvSpPr>
-        <p:spPr>
-          <a:xfrm>
-            <a:off x="6477000" y="3098800"/>
-            <a:ext cx="1993900" cy="990600"/>
-          </a:xfrm>
-          <a:prstGeom prst="rect">
-            <a:avLst/>
-          </a:prstGeom>
-          <a:noFill/>
-          <a:ln>
-            <a:noFill/>
-          </a:ln>
-          <a:effectLst/>
-        </p:spPr>
-        <p:txBody>
-          <a:bodyPr wrap="square" lIns="0" tIns="0" rIns="0" bIns="0" anchor="t">
-            <a:noAutofit/>
-          </a:bodyPr>
-          <a:lstStyle/>
-          <a:p>
-            <a:pPr>
-              <a:lnSpc>
-                <a:spcPct val="125000"/>
-              </a:lnSpc>
-              <a:buNone/>
-            </a:pPr>
-            <a:r>
-              <a:rPr lang="fr-FR" sz="950" b="0" dirty="0">
-                <a:solidFill>
-                  <a:srgbClr val="4C5C72"/>
-                </a:solidFill>
-                <a:latin typeface="Segoe UI"/>
-                <a:cs typeface="Segoe UI"/>
-              </a:rPr>
-              <a:t>Articles copiés mot à mot, références complètes, URL jamais inventée : « N/A » si l'information manque.</a:t>
-            </a:r>
-            <a:endParaRPr lang="fr-FR" sz="100"/>
-          </a:p>
-        </p:txBody>
-      </p:sp>
-      <p:sp>
-        <p:nvSpPr>
-          <p:cNvPr id="33" name="forme"/>
-          <p:cNvSpPr/>
-          <p:nvPr/>
-        </p:nvSpPr>
-        <p:spPr>
-          <a:xfrm>
-            <a:off x="8978900" y="1778000"/>
-            <a:ext cx="2501900" cy="2489200"/>
-          </a:xfrm>
-          <a:prstGeom prst="roundRect">
-            <a:avLst>
-              <a:gd name="adj" fmla="val 12245"/>
-            </a:avLst>
-          </a:prstGeom>
-          <a:solidFill>
-            <a:srgbClr val="FFFFFF"/>
-          </a:solidFill>
-          <a:ln w="9525" cap="flat">
-            <a:solidFill>
-              <a:srgbClr val="DCE3EE"/>
-            </a:solidFill>
-            <a:prstDash val="solid"/>
-            <a:flat/>
-          </a:ln>
-          <a:effectLst>
-            <a:outerShdw blurRad="127000" dist="31750" dir="5400000" rotWithShape="0">
-              <a:srgbClr val="0B1A30">
-                <a:alpha val="8000"/>
-              </a:srgbClr>
-            </a:outerShdw>
-          </a:effectLst>
-        </p:spPr>
-        <p:txBody>
-          <a:bodyPr/>
-          <a:lstStyle/>
-          <a:p>
-            <a:endParaRPr lang="fr-FR"/>
-          </a:p>
-        </p:txBody>
-      </p:sp>
-      <p:sp>
-        <p:nvSpPr>
-          <p:cNvPr id="34" name="forme"/>
-          <p:cNvSpPr/>
-          <p:nvPr/>
-        </p:nvSpPr>
-        <p:spPr>
-          <a:xfrm>
-            <a:off x="8978900" y="1778000"/>
-            <a:ext cx="50800" cy="2489200"/>
-          </a:xfrm>
-          <a:prstGeom prst="roundRect">
-            <a:avLst>
-              <a:gd name="adj" fmla="val 50000"/>
-            </a:avLst>
-          </a:prstGeom>
-          <a:solidFill>
-            <a:srgbClr val="B6AD6E"/>
-          </a:solidFill>
-          <a:ln>
-            <a:noFill/>
-          </a:ln>
-          <a:effectLst/>
-        </p:spPr>
-        <p:txBody>
-          <a:bodyPr/>
-          <a:lstStyle/>
-          <a:p>
-            <a:endParaRPr lang="fr-FR"/>
-          </a:p>
-        </p:txBody>
-      </p:sp>
-      <p:sp>
-        <p:nvSpPr>
-          <p:cNvPr id="35" name="forme"/>
-          <p:cNvSpPr/>
-          <p:nvPr/>
-        </p:nvSpPr>
-        <p:spPr>
-          <a:xfrm>
-            <a:off x="9232900" y="2032000"/>
-            <a:ext cx="482600" cy="482600"/>
-          </a:xfrm>
-          <a:prstGeom prst="roundRect">
-            <a:avLst>
-              <a:gd name="adj" fmla="val 50000"/>
-            </a:avLst>
-          </a:prstGeom>
-          <a:solidFill>
-            <a:srgbClr val="1C3359"/>
-          </a:solidFill>
-          <a:ln>
-            <a:noFill/>
-          </a:ln>
-          <a:effectLst/>
-        </p:spPr>
-        <p:txBody>
-          <a:bodyPr/>
-          <a:lstStyle/>
-          <a:p>
-            <a:endParaRPr lang="fr-FR"/>
-          </a:p>
-        </p:txBody>
-      </p:sp>
-      <p:sp>
-        <p:nvSpPr>
-          <p:cNvPr id="36" name="forme"/>
-          <p:cNvSpPr/>
-          <p:nvPr/>
-        </p:nvSpPr>
-        <p:spPr>
-          <a:xfrm>
-            <a:off x="9363781" y="2187976"/>
-            <a:ext cx="220838" cy="195743"/>
-          </a:xfrm>
-          <a:prstGeom prst="rect">
-            <a:avLst/>
-          </a:prstGeom>
-          <a:solidFill>
-            <a:srgbClr val="FFFFFF"/>
-          </a:solidFill>
-          <a:ln>
-            <a:noFill/>
-          </a:ln>
-          <a:effectLst/>
-        </p:spPr>
-        <p:txBody>
-          <a:bodyPr/>
-          <a:lstStyle/>
-          <a:p>
-            <a:endParaRPr lang="fr-FR"/>
-          </a:p>
-        </p:txBody>
-      </p:sp>
-      <p:sp>
-        <p:nvSpPr>
-          <p:cNvPr id="37" name="forme"/>
-          <p:cNvSpPr/>
-          <p:nvPr/>
-        </p:nvSpPr>
-        <p:spPr>
-          <a:xfrm>
-            <a:off x="9363781" y="2187976"/>
-            <a:ext cx="220838" cy="45171"/>
-          </a:xfrm>
-          <a:prstGeom prst="rect">
-            <a:avLst/>
-          </a:prstGeom>
-          <a:solidFill>
-            <a:srgbClr val="1C3359"/>
-          </a:solidFill>
-          <a:ln>
-            <a:noFill/>
-          </a:ln>
-          <a:effectLst/>
-        </p:spPr>
-        <p:txBody>
-          <a:bodyPr/>
-          <a:lstStyle/>
-          <a:p>
-            <a:endParaRPr lang="fr-FR"/>
-          </a:p>
-        </p:txBody>
-      </p:sp>
-      <p:sp>
-        <p:nvSpPr>
-          <p:cNvPr id="38" name="forme"/>
-          <p:cNvSpPr/>
-          <p:nvPr/>
-        </p:nvSpPr>
-        <p:spPr>
-          <a:xfrm>
-            <a:off x="9408952" y="2157862"/>
-            <a:ext cx="27605" cy="55209"/>
-          </a:xfrm>
-          <a:prstGeom prst="roundRect">
-            <a:avLst>
-              <a:gd name="adj" fmla="val 50000"/>
-            </a:avLst>
-          </a:prstGeom>
-          <a:solidFill>
-            <a:srgbClr val="FFFFFF"/>
-          </a:solidFill>
-          <a:ln>
-            <a:noFill/>
-          </a:ln>
-          <a:effectLst/>
-        </p:spPr>
-        <p:txBody>
-          <a:bodyPr/>
-          <a:lstStyle/>
-          <a:p>
-            <a:endParaRPr lang="fr-FR"/>
-          </a:p>
-        </p:txBody>
-      </p:sp>
-      <p:sp>
-        <p:nvSpPr>
-          <p:cNvPr id="39" name="forme"/>
-          <p:cNvSpPr/>
-          <p:nvPr/>
-        </p:nvSpPr>
-        <p:spPr>
-          <a:xfrm>
-            <a:off x="9511843" y="2157862"/>
-            <a:ext cx="27605" cy="55209"/>
-          </a:xfrm>
-          <a:prstGeom prst="roundRect">
-            <a:avLst>
-              <a:gd name="adj" fmla="val 50000"/>
-            </a:avLst>
-          </a:prstGeom>
-          <a:solidFill>
-            <a:srgbClr val="FFFFFF"/>
-          </a:solidFill>
-          <a:ln>
-            <a:noFill/>
-          </a:ln>
-          <a:effectLst/>
-        </p:spPr>
-        <p:txBody>
-          <a:bodyPr/>
-          <a:lstStyle/>
-          <a:p>
-            <a:endParaRPr lang="fr-FR"/>
-          </a:p>
-        </p:txBody>
-      </p:sp>
-      <p:sp>
-        <p:nvSpPr>
-          <p:cNvPr id="40" name="forme"/>
-          <p:cNvSpPr/>
-          <p:nvPr/>
-        </p:nvSpPr>
-        <p:spPr>
-          <a:xfrm>
-            <a:off x="9408952" y="2268281"/>
-            <a:ext cx="37643" cy="27605"/>
-          </a:xfrm>
-          <a:prstGeom prst="rect">
-            <a:avLst/>
-          </a:prstGeom>
-          <a:solidFill>
-            <a:srgbClr val="1C3359"/>
+            <a:srgbClr val="2C4A78"/>
           </a:solidFill>
           <a:ln>
             <a:noFill/>
@@ -9661,282 +9711,6 @@
       <p:sp>
         <p:nvSpPr>
           <p:cNvPr id="41" name="forme"/>
-          <p:cNvSpPr/>
-          <p:nvPr/>
-        </p:nvSpPr>
-        <p:spPr>
-          <a:xfrm>
-            <a:off x="9469181" y="2268281"/>
-            <a:ext cx="37643" cy="27605"/>
-          </a:xfrm>
-          <a:prstGeom prst="rect">
-            <a:avLst/>
-          </a:prstGeom>
-          <a:solidFill>
-            <a:srgbClr val="1C3359"/>
-          </a:solidFill>
-          <a:ln>
-            <a:noFill/>
-          </a:ln>
-          <a:effectLst/>
-        </p:spPr>
-        <p:txBody>
-          <a:bodyPr/>
-          <a:lstStyle/>
-          <a:p>
-            <a:endParaRPr lang="fr-FR"/>
-          </a:p>
-        </p:txBody>
-      </p:sp>
-      <p:sp>
-        <p:nvSpPr>
-          <p:cNvPr id="42" name="forme"/>
-          <p:cNvSpPr/>
-          <p:nvPr/>
-        </p:nvSpPr>
-        <p:spPr>
-          <a:xfrm>
-            <a:off x="9529409" y="2268281"/>
-            <a:ext cx="12548" cy="27605"/>
-          </a:xfrm>
-          <a:prstGeom prst="rect">
-            <a:avLst/>
-          </a:prstGeom>
-          <a:solidFill>
-            <a:srgbClr val="1C3359"/>
-          </a:solidFill>
-          <a:ln>
-            <a:noFill/>
-          </a:ln>
-          <a:effectLst/>
-        </p:spPr>
-        <p:txBody>
-          <a:bodyPr/>
-          <a:lstStyle/>
-          <a:p>
-            <a:endParaRPr lang="fr-FR"/>
-          </a:p>
-        </p:txBody>
-      </p:sp>
-      <p:sp>
-        <p:nvSpPr>
-          <p:cNvPr id="43" name="forme"/>
-          <p:cNvSpPr/>
-          <p:nvPr/>
-        </p:nvSpPr>
-        <p:spPr>
-          <a:xfrm>
-            <a:off x="9408952" y="2318471"/>
-            <a:ext cx="37643" cy="27605"/>
-          </a:xfrm>
-          <a:prstGeom prst="rect">
-            <a:avLst/>
-          </a:prstGeom>
-          <a:solidFill>
-            <a:srgbClr val="1C3359"/>
-          </a:solidFill>
-          <a:ln>
-            <a:noFill/>
-          </a:ln>
-          <a:effectLst/>
-        </p:spPr>
-        <p:txBody>
-          <a:bodyPr/>
-          <a:lstStyle/>
-          <a:p>
-            <a:endParaRPr lang="fr-FR"/>
-          </a:p>
-        </p:txBody>
-      </p:sp>
-      <p:sp>
-        <p:nvSpPr>
-          <p:cNvPr id="44" name="forme"/>
-          <p:cNvSpPr/>
-          <p:nvPr/>
-        </p:nvSpPr>
-        <p:spPr>
-          <a:xfrm>
-            <a:off x="9469181" y="2318471"/>
-            <a:ext cx="37643" cy="27605"/>
-          </a:xfrm>
-          <a:prstGeom prst="rect">
-            <a:avLst/>
-          </a:prstGeom>
-          <a:solidFill>
-            <a:srgbClr val="1C3359"/>
-          </a:solidFill>
-          <a:ln>
-            <a:noFill/>
-          </a:ln>
-          <a:effectLst/>
-        </p:spPr>
-        <p:txBody>
-          <a:bodyPr/>
-          <a:lstStyle/>
-          <a:p>
-            <a:endParaRPr lang="fr-FR"/>
-          </a:p>
-        </p:txBody>
-      </p:sp>
-      <p:sp>
-        <p:nvSpPr>
-          <p:cNvPr id="45" name="forme"/>
-          <p:cNvSpPr/>
-          <p:nvPr/>
-        </p:nvSpPr>
-        <p:spPr>
-          <a:xfrm>
-            <a:off x="9232900" y="2641600"/>
-            <a:ext cx="1993900" cy="431800"/>
-          </a:xfrm>
-          <a:prstGeom prst="rect">
-            <a:avLst/>
-          </a:prstGeom>
-          <a:noFill/>
-          <a:ln>
-            <a:noFill/>
-          </a:ln>
-          <a:effectLst/>
-        </p:spPr>
-        <p:txBody>
-          <a:bodyPr wrap="square" lIns="0" tIns="0" rIns="0" bIns="0" anchor="t">
-            <a:noAutofit/>
-          </a:bodyPr>
-          <a:lstStyle/>
-          <a:p>
-            <a:pPr>
-              <a:lnSpc>
-                <a:spcPct val="106000"/>
-              </a:lnSpc>
-              <a:buNone/>
-            </a:pPr>
-            <a:r>
-              <a:rPr lang="fr-FR" sz="1250" b="1" dirty="0">
-                <a:solidFill>
-                  <a:srgbClr val="1C3359"/>
-                </a:solidFill>
-                <a:latin typeface="Segoe UI"/>
-                <a:cs typeface="Segoe UI"/>
-              </a:rPr>
-              <a:t>Jalons &amp; fraîcheur</a:t>
-            </a:r>
-            <a:endParaRPr lang="fr-FR" sz="100"/>
-          </a:p>
-        </p:txBody>
-      </p:sp>
-      <p:sp>
-        <p:nvSpPr>
-          <p:cNvPr id="46" name="forme"/>
-          <p:cNvSpPr/>
-          <p:nvPr/>
-        </p:nvSpPr>
-        <p:spPr>
-          <a:xfrm>
-            <a:off x="9232900" y="3098800"/>
-            <a:ext cx="1993900" cy="990600"/>
-          </a:xfrm>
-          <a:prstGeom prst="rect">
-            <a:avLst/>
-          </a:prstGeom>
-          <a:noFill/>
-          <a:ln>
-            <a:noFill/>
-          </a:ln>
-          <a:effectLst/>
-        </p:spPr>
-        <p:txBody>
-          <a:bodyPr wrap="square" lIns="0" tIns="0" rIns="0" bIns="0" anchor="t">
-            <a:noAutofit/>
-          </a:bodyPr>
-          <a:lstStyle/>
-          <a:p>
-            <a:pPr>
-              <a:lnSpc>
-                <a:spcPct val="125000"/>
-              </a:lnSpc>
-              <a:buNone/>
-            </a:pPr>
-            <a:r>
-              <a:rPr lang="fr-FR" sz="950" b="0" dirty="0">
-                <a:solidFill>
-                  <a:srgbClr val="4C5C72"/>
-                </a:solidFill>
-                <a:latin typeface="Segoe UI"/>
-                <a:cs typeface="Segoe UI"/>
-              </a:rPr>
-              <a:t>Assignée le, validée le, rejetée le, en attente depuis N jours, dernière mise à jour et date d'application de l'outil.</a:t>
-            </a:r>
-            <a:endParaRPr lang="fr-FR" sz="100"/>
-          </a:p>
-        </p:txBody>
-      </p:sp>
-      <p:sp>
-        <p:nvSpPr>
-          <p:cNvPr id="47" name="forme"/>
-          <p:cNvSpPr/>
-          <p:nvPr/>
-        </p:nvSpPr>
-        <p:spPr>
-          <a:xfrm>
-            <a:off x="711200" y="4597400"/>
-            <a:ext cx="10769600" cy="1422400"/>
-          </a:xfrm>
-          <a:prstGeom prst="roundRect">
-            <a:avLst>
-              <a:gd name="adj" fmla="val 21429"/>
-            </a:avLst>
-          </a:prstGeom>
-          <a:solidFill>
-            <a:srgbClr val="1C3359"/>
-          </a:solidFill>
-          <a:ln>
-            <a:noFill/>
-          </a:ln>
-          <a:effectLst/>
-        </p:spPr>
-        <p:txBody>
-          <a:bodyPr/>
-          <a:lstStyle/>
-          <a:p>
-            <a:endParaRPr lang="fr-FR"/>
-          </a:p>
-        </p:txBody>
-      </p:sp>
-      <p:sp>
-        <p:nvSpPr>
-          <p:cNvPr id="48" name="forme"/>
-          <p:cNvSpPr/>
-          <p:nvPr/>
-        </p:nvSpPr>
-        <p:spPr>
-          <a:xfrm>
-            <a:off x="990600" y="5054600"/>
-            <a:ext cx="508000" cy="508000"/>
-          </a:xfrm>
-          <a:prstGeom prst="roundRect">
-            <a:avLst>
-              <a:gd name="adj" fmla="val 50000"/>
-            </a:avLst>
-          </a:prstGeom>
-          <a:solidFill>
-            <a:srgbClr val="2C4A78"/>
-          </a:solidFill>
-          <a:ln>
-            <a:noFill/>
-          </a:ln>
-          <a:effectLst/>
-        </p:spPr>
-        <p:txBody>
-          <a:bodyPr/>
-          <a:lstStyle/>
-          <a:p>
-            <a:endParaRPr lang="fr-FR"/>
-          </a:p>
-        </p:txBody>
-      </p:sp>
-      <p:sp>
-        <p:nvSpPr>
-          <p:cNvPr id="49" name="forme"/>
           <p:cNvSpPr/>
           <p:nvPr/>
         </p:nvSpPr>
@@ -9968,7 +9742,7 @@
       </p:sp>
       <p:sp>
         <p:nvSpPr>
-          <p:cNvPr id="50" name="forme"/>
+          <p:cNvPr id="42" name="forme"/>
           <p:cNvSpPr/>
           <p:nvPr/>
         </p:nvSpPr>
@@ -10000,7 +9774,7 @@
       </p:sp>
       <p:sp>
         <p:nvSpPr>
-          <p:cNvPr id="51" name="forme"/>
+          <p:cNvPr id="43" name="forme"/>
           <p:cNvSpPr/>
           <p:nvPr/>
         </p:nvSpPr>
@@ -10032,7 +9806,7 @@
       </p:sp>
       <p:sp>
         <p:nvSpPr>
-          <p:cNvPr id="52" name="forme"/>
+          <p:cNvPr id="44" name="forme"/>
           <p:cNvSpPr/>
           <p:nvPr/>
         </p:nvSpPr>
@@ -10075,7 +9849,7 @@
       </p:sp>
       <p:sp>
         <p:nvSpPr>
-          <p:cNvPr id="53" name="forme"/>
+          <p:cNvPr id="45" name="forme"/>
           <p:cNvSpPr/>
           <p:nvPr/>
         </p:nvSpPr>
@@ -10118,7 +9892,7 @@
       </p:sp>
       <p:sp>
         <p:nvSpPr>
-          <p:cNvPr id="54" name="forme"/>
+          <p:cNvPr id="46" name="forme"/>
           <p:cNvSpPr/>
           <p:nvPr/>
         </p:nvSpPr>
@@ -10148,7 +9922,7 @@
       </p:sp>
       <p:sp>
         <p:nvSpPr>
-          <p:cNvPr id="55" name="forme"/>
+          <p:cNvPr id="47" name="forme"/>
           <p:cNvSpPr/>
           <p:nvPr/>
         </p:nvSpPr>
@@ -10188,7 +9962,7 @@
       </p:sp>
       <p:sp>
         <p:nvSpPr>
-          <p:cNvPr id="56" name="forme"/>
+          <p:cNvPr id="48" name="forme"/>
           <p:cNvSpPr/>
           <p:nvPr/>
         </p:nvSpPr>
@@ -10231,7 +10005,7 @@
       </p:sp>
       <p:sp>
         <p:nvSpPr>
-          <p:cNvPr id="57" name="forme"/>
+          <p:cNvPr id="49" name="forme"/>
           <p:cNvSpPr/>
           <p:nvPr/>
         </p:nvSpPr>
@@ -10261,7 +10035,7 @@
       </p:sp>
       <p:sp>
         <p:nvSpPr>
-          <p:cNvPr id="58" name="forme"/>
+          <p:cNvPr id="50" name="forme"/>
           <p:cNvSpPr/>
           <p:nvPr/>
         </p:nvSpPr>
@@ -10301,7 +10075,7 @@
       </p:sp>
       <p:sp>
         <p:nvSpPr>
-          <p:cNvPr id="59" name="forme"/>
+          <p:cNvPr id="51" name="forme"/>
           <p:cNvSpPr/>
           <p:nvPr/>
         </p:nvSpPr>
@@ -10344,7 +10118,7 @@
       </p:sp>
       <p:sp>
         <p:nvSpPr>
-          <p:cNvPr id="60" name="forme"/>
+          <p:cNvPr id="52" name="forme"/>
           <p:cNvSpPr/>
           <p:nvPr/>
         </p:nvSpPr>
@@ -10374,7 +10148,7 @@
       </p:sp>
       <p:sp>
         <p:nvSpPr>
-          <p:cNvPr id="61" name="forme"/>
+          <p:cNvPr id="53" name="forme"/>
           <p:cNvSpPr/>
           <p:nvPr/>
         </p:nvSpPr>
@@ -10414,7 +10188,7 @@
       </p:sp>
       <p:sp>
         <p:nvSpPr>
-          <p:cNvPr id="62" name="forme"/>
+          <p:cNvPr id="54" name="forme"/>
           <p:cNvSpPr/>
           <p:nvPr/>
         </p:nvSpPr>
@@ -10457,7 +10231,7 @@
       </p:sp>
       <p:sp>
         <p:nvSpPr>
-          <p:cNvPr id="63" name="forme"/>
+          <p:cNvPr id="55" name="forme"/>
           <p:cNvSpPr/>
           <p:nvPr/>
         </p:nvSpPr>
@@ -10487,7 +10261,7 @@
       </p:sp>
       <p:sp>
         <p:nvSpPr>
-          <p:cNvPr id="64" name="forme"/>
+          <p:cNvPr id="56" name="forme"/>
           <p:cNvSpPr/>
           <p:nvPr/>
         </p:nvSpPr>
@@ -10527,7 +10301,7 @@
       </p:sp>
       <p:sp>
         <p:nvSpPr>
-          <p:cNvPr id="65" name="forme"/>
+          <p:cNvPr id="57" name="forme"/>
           <p:cNvSpPr/>
           <p:nvPr/>
         </p:nvSpPr>
@@ -10570,7 +10344,7 @@
       </p:sp>
       <p:sp>
         <p:nvSpPr>
-          <p:cNvPr id="66" name="forme"/>
+          <p:cNvPr id="58" name="forme"/>
           <p:cNvSpPr/>
           <p:nvPr/>
         </p:nvSpPr>
@@ -10600,7 +10374,7 @@
       </p:sp>
       <p:sp>
         <p:nvSpPr>
-          <p:cNvPr id="67" name="forme"/>
+          <p:cNvPr id="59" name="forme"/>
           <p:cNvSpPr/>
           <p:nvPr/>
         </p:nvSpPr>
@@ -10653,7 +10427,7 @@
       </p:sp>
       <p:sp>
         <p:nvSpPr>
-          <p:cNvPr id="68" name="forme"/>
+          <p:cNvPr id="60" name="forme"/>
           <p:cNvSpPr/>
           <p:nvPr/>
         </p:nvSpPr>
@@ -11471,7 +11245,7 @@
                 <a:latin typeface="Segoe UI"/>
                 <a:cs typeface="Segoe UI"/>
               </a:rPr>
-              <a:t>Un seul point à basculer : l'identité, par Entra ID et Web Roles</a:t>
+              <a:t>Deux points à basculer : lireSession (serveur) et la pastille d’identité</a:t>
             </a:r>
             <a:endParaRPr lang="fr-FR" sz="100"/>
           </a:p>
@@ -12154,7 +11928,7 @@
                 <a:latin typeface="Segoe UI"/>
                 <a:cs typeface="Segoe UI"/>
               </a:rPr>
-              <a:t>Brancher l'API sur Dataverse et activer l'auditing natif</a:t>
+              <a:t>Brancher l'API sur Dataverse et activer l’auditing natif</a:t>
             </a:r>
             <a:endParaRPr lang="fr-FR" sz="100"/>
           </a:p>
@@ -12303,7 +12077,7 @@
                 <a:latin typeface="Segoe UI"/>
                 <a:cs typeface="Segoe UI"/>
               </a:rPr>
-              <a:t>Piloter la recette avec les directions, puis basculer l'identité</a:t>
+              <a:t>Basculer l'identité sur Entra ID avec les directions</a:t>
             </a:r>
             <a:endParaRPr lang="fr-FR" sz="100"/>
           </a:p>
@@ -12420,7 +12194,7 @@
                 <a:latin typeface="Segoe UI"/>
                 <a:cs typeface="Segoe UI"/>
               </a:rPr>
-              <a:t>démo live : Pilotage → Nouvelle alerte → Validation → Approbation → Historique</a:t>
+              <a:t>démo live : Connexion → Assignation → Approbation → Vue immersive → Historique</a:t>
             </a:r>
             <a:endParaRPr lang="fr-FR" sz="100"/>
           </a:p>

</xml_diff>